<commit_message>
Update Gewinnmarge zu Gewinnbetrag
</commit_message>
<xml_diff>
--- a/Präsentation/Präsentation.pptx
+++ b/Präsentation/Präsentation.pptx
@@ -209,7 +209,7 @@
           <a:p>
             <a:fld id="{7644AF23-4141-471D-8F47-D0D465B8A2CC}" type="datetimeFigureOut">
               <a:rPr lang="de-DE" smtClean="0"/>
-              <a:t>26.08.2026</a:t>
+              <a:t>27.08.2026</a:t>
             </a:fld>
             <a:endParaRPr lang="de-DE"/>
           </a:p>
@@ -733,7 +733,7 @@
             </a:pPr>
             <a:r>
               <a:rPr lang="de-DE" dirty="0"/>
-              <a:t>Stand: Mittwoch 17:10</a:t>
+              <a:t>Stand: Donnerstag 10:33</a:t>
             </a:r>
           </a:p>
           <a:p>
@@ -840,7 +840,7 @@
             </a:pPr>
             <a:r>
               <a:rPr lang="de-DE" dirty="0"/>
-              <a:t>Stand: Mittwoch 17:11</a:t>
+              <a:t>Stand: Donnerstag 10:33</a:t>
             </a:r>
           </a:p>
           <a:p>
@@ -1031,7 +1031,7 @@
           <a:p>
             <a:fld id="{573F7FC6-07F6-421A-8FD9-92A0CA065868}" type="datetimeFigureOut">
               <a:rPr lang="de-DE" smtClean="0"/>
-              <a:t>26.08.2026</a:t>
+              <a:t>27.08.2026</a:t>
             </a:fld>
             <a:endParaRPr lang="de-DE"/>
           </a:p>
@@ -1229,7 +1229,7 @@
           <a:p>
             <a:fld id="{573F7FC6-07F6-421A-8FD9-92A0CA065868}" type="datetimeFigureOut">
               <a:rPr lang="de-DE" smtClean="0"/>
-              <a:t>26.08.2026</a:t>
+              <a:t>27.08.2026</a:t>
             </a:fld>
             <a:endParaRPr lang="de-DE"/>
           </a:p>
@@ -1437,7 +1437,7 @@
           <a:p>
             <a:fld id="{573F7FC6-07F6-421A-8FD9-92A0CA065868}" type="datetimeFigureOut">
               <a:rPr lang="de-DE" smtClean="0"/>
-              <a:t>26.08.2026</a:t>
+              <a:t>27.08.2026</a:t>
             </a:fld>
             <a:endParaRPr lang="de-DE"/>
           </a:p>
@@ -1635,7 +1635,7 @@
           <a:p>
             <a:fld id="{573F7FC6-07F6-421A-8FD9-92A0CA065868}" type="datetimeFigureOut">
               <a:rPr lang="de-DE" smtClean="0"/>
-              <a:t>26.08.2026</a:t>
+              <a:t>27.08.2026</a:t>
             </a:fld>
             <a:endParaRPr lang="de-DE"/>
           </a:p>
@@ -1910,7 +1910,7 @@
           <a:p>
             <a:fld id="{573F7FC6-07F6-421A-8FD9-92A0CA065868}" type="datetimeFigureOut">
               <a:rPr lang="de-DE" smtClean="0"/>
-              <a:t>26.08.2026</a:t>
+              <a:t>27.08.2026</a:t>
             </a:fld>
             <a:endParaRPr lang="de-DE"/>
           </a:p>
@@ -2175,7 +2175,7 @@
           <a:p>
             <a:fld id="{573F7FC6-07F6-421A-8FD9-92A0CA065868}" type="datetimeFigureOut">
               <a:rPr lang="de-DE" smtClean="0"/>
-              <a:t>26.08.2026</a:t>
+              <a:t>27.08.2026</a:t>
             </a:fld>
             <a:endParaRPr lang="de-DE"/>
           </a:p>
@@ -2587,7 +2587,7 @@
           <a:p>
             <a:fld id="{573F7FC6-07F6-421A-8FD9-92A0CA065868}" type="datetimeFigureOut">
               <a:rPr lang="de-DE" smtClean="0"/>
-              <a:t>26.08.2026</a:t>
+              <a:t>27.08.2026</a:t>
             </a:fld>
             <a:endParaRPr lang="de-DE"/>
           </a:p>
@@ -2728,7 +2728,7 @@
           <a:p>
             <a:fld id="{573F7FC6-07F6-421A-8FD9-92A0CA065868}" type="datetimeFigureOut">
               <a:rPr lang="de-DE" smtClean="0"/>
-              <a:t>26.08.2026</a:t>
+              <a:t>27.08.2026</a:t>
             </a:fld>
             <a:endParaRPr lang="de-DE"/>
           </a:p>
@@ -2841,7 +2841,7 @@
           <a:p>
             <a:fld id="{573F7FC6-07F6-421A-8FD9-92A0CA065868}" type="datetimeFigureOut">
               <a:rPr lang="de-DE" smtClean="0"/>
-              <a:t>26.08.2026</a:t>
+              <a:t>27.08.2026</a:t>
             </a:fld>
             <a:endParaRPr lang="de-DE"/>
           </a:p>
@@ -3152,7 +3152,7 @@
           <a:p>
             <a:fld id="{573F7FC6-07F6-421A-8FD9-92A0CA065868}" type="datetimeFigureOut">
               <a:rPr lang="de-DE" smtClean="0"/>
-              <a:t>26.08.2026</a:t>
+              <a:t>27.08.2026</a:t>
             </a:fld>
             <a:endParaRPr lang="de-DE"/>
           </a:p>
@@ -3440,7 +3440,7 @@
           <a:p>
             <a:fld id="{573F7FC6-07F6-421A-8FD9-92A0CA065868}" type="datetimeFigureOut">
               <a:rPr lang="de-DE" smtClean="0"/>
-              <a:t>26.08.2026</a:t>
+              <a:t>27.08.2026</a:t>
             </a:fld>
             <a:endParaRPr lang="de-DE"/>
           </a:p>
@@ -3681,7 +3681,7 @@
           <a:p>
             <a:fld id="{573F7FC6-07F6-421A-8FD9-92A0CA065868}" type="datetimeFigureOut">
               <a:rPr lang="de-DE" smtClean="0"/>
-              <a:t>26.08.2026</a:t>
+              <a:t>27.08.2026</a:t>
             </a:fld>
             <a:endParaRPr lang="de-DE"/>
           </a:p>

</xml_diff>

<commit_message>
Präsentation überarbeitet und ETL Dimension Zeit_ einmaliges Laden
</commit_message>
<xml_diff>
--- a/Präsentation/Präsentation.pptx
+++ b/Präsentation/Präsentation.pptx
@@ -5,7 +5,7 @@
     <p:sldMasterId id="2147483648" r:id="rId1"/>
   </p:sldMasterIdLst>
   <p:notesMasterIdLst>
-    <p:notesMasterId r:id="rId16"/>
+    <p:notesMasterId r:id="rId14"/>
   </p:notesMasterIdLst>
   <p:sldIdLst>
     <p:sldId id="256" r:id="rId2"/>
@@ -13,15 +13,13 @@
     <p:sldId id="263" r:id="rId4"/>
     <p:sldId id="258" r:id="rId5"/>
     <p:sldId id="269" r:id="rId6"/>
-    <p:sldId id="259" r:id="rId7"/>
-    <p:sldId id="260" r:id="rId8"/>
-    <p:sldId id="261" r:id="rId9"/>
-    <p:sldId id="262" r:id="rId10"/>
-    <p:sldId id="264" r:id="rId11"/>
-    <p:sldId id="265" r:id="rId12"/>
-    <p:sldId id="266" r:id="rId13"/>
-    <p:sldId id="267" r:id="rId14"/>
-    <p:sldId id="268" r:id="rId15"/>
+    <p:sldId id="262" r:id="rId7"/>
+    <p:sldId id="264" r:id="rId8"/>
+    <p:sldId id="265" r:id="rId9"/>
+    <p:sldId id="266" r:id="rId10"/>
+    <p:sldId id="267" r:id="rId11"/>
+    <p:sldId id="268" r:id="rId12"/>
+    <p:sldId id="270" r:id="rId13"/>
   </p:sldIdLst>
   <p:sldSz cx="12192000" cy="6858000"/>
   <p:notesSz cx="6858000" cy="9144000"/>
@@ -734,7 +732,7 @@
           <a:p>
             <a:fld id="{F9573A14-2FD9-4F88-9CDD-7A01E9A13A5F}" type="slidenum">
               <a:rPr lang="de-DE" smtClean="0"/>
-              <a:t>11</a:t>
+              <a:t>8</a:t>
             </a:fld>
             <a:endParaRPr lang="de-DE"/>
           </a:p>
@@ -818,7 +816,7 @@
           <a:p>
             <a:fld id="{F9573A14-2FD9-4F88-9CDD-7A01E9A13A5F}" type="slidenum">
               <a:rPr lang="de-DE" smtClean="0"/>
-              <a:t>12</a:t>
+              <a:t>9</a:t>
             </a:fld>
             <a:endParaRPr lang="de-DE"/>
           </a:p>
@@ -902,7 +900,7 @@
           <a:p>
             <a:fld id="{F9573A14-2FD9-4F88-9CDD-7A01E9A13A5F}" type="slidenum">
               <a:rPr lang="de-DE" smtClean="0"/>
-              <a:t>13</a:t>
+              <a:t>10</a:t>
             </a:fld>
             <a:endParaRPr lang="de-DE"/>
           </a:p>
@@ -4240,7 +4238,13 @@
   <p:cSld>
     <p:spTree>
       <p:nvGrpSpPr>
-        <p:cNvPr id="1" name=""/>
+        <p:cNvPr id="1" name="">
+          <a:extLst>
+            <a:ext uri="{FF2B5EF4-FFF2-40B4-BE49-F238E27FC236}">
+              <a16:creationId xmlns:a16="http://schemas.microsoft.com/office/drawing/2014/main" id="{B0A518B4-6F6D-629A-78BB-C72612DF9CCA}"/>
+            </a:ext>
+          </a:extLst>
+        </p:cNvPr>
         <p:cNvGrpSpPr/>
         <p:nvPr/>
       </p:nvGrpSpPr>
@@ -4254,10 +4258,10 @@
       </p:grpSpPr>
       <p:sp>
         <p:nvSpPr>
-          <p:cNvPr id="4" name="Titel 3">
-            <a:extLst>
-              <a:ext uri="{FF2B5EF4-FFF2-40B4-BE49-F238E27FC236}">
-                <a16:creationId xmlns:a16="http://schemas.microsoft.com/office/drawing/2014/main" id="{7FBC5EB2-8E38-A6FF-3747-7C0FBA075449}"/>
+          <p:cNvPr id="2" name="Titel 1">
+            <a:extLst>
+              <a:ext uri="{FF2B5EF4-FFF2-40B4-BE49-F238E27FC236}">
+                <a16:creationId xmlns:a16="http://schemas.microsoft.com/office/drawing/2014/main" id="{381B224B-06D3-B13F-1F18-6E1D0094E5FF}"/>
               </a:ext>
             </a:extLst>
           </p:cNvPr>
@@ -4275,106 +4279,248 @@
           <a:p>
             <a:r>
               <a:rPr lang="de-DE" dirty="0"/>
-              <a:t>DWH-Fragen</a:t>
-            </a:r>
-          </a:p>
-        </p:txBody>
-      </p:sp>
-      <p:sp>
-        <p:nvSpPr>
-          <p:cNvPr id="5" name="Inhaltsplatzhalter 4">
-            <a:extLst>
-              <a:ext uri="{FF2B5EF4-FFF2-40B4-BE49-F238E27FC236}">
-                <a16:creationId xmlns:a16="http://schemas.microsoft.com/office/drawing/2014/main" id="{CE1C7ED1-A131-55DE-7840-35E53E3E2D37}"/>
-              </a:ext>
-            </a:extLst>
-          </p:cNvPr>
-          <p:cNvSpPr>
-            <a:spLocks noGrp="1"/>
-          </p:cNvSpPr>
-          <p:nvPr>
-            <p:ph idx="1"/>
-          </p:nvPr>
-        </p:nvSpPr>
-        <p:spPr/>
-        <p:txBody>
-          <a:bodyPr>
-            <a:normAutofit fontScale="92500" lnSpcReduction="10000"/>
+              <a:t>Logisches Modell</a:t>
+            </a:r>
+            <a:br>
+              <a:rPr lang="de-DE" dirty="0"/>
+            </a:br>
+            <a:r>
+              <a:rPr lang="de-DE" dirty="0"/>
+              <a:t>Galaxy Schema</a:t>
+            </a:r>
+          </a:p>
+        </p:txBody>
+      </p:sp>
+      <p:sp>
+        <p:nvSpPr>
+          <p:cNvPr id="3" name="Textfeld 2">
+            <a:extLst>
+              <a:ext uri="{FF2B5EF4-FFF2-40B4-BE49-F238E27FC236}">
+                <a16:creationId xmlns:a16="http://schemas.microsoft.com/office/drawing/2014/main" id="{91E45CDD-F47D-7F96-C9A6-A43E20426182}"/>
+              </a:ext>
+            </a:extLst>
+          </p:cNvPr>
+          <p:cNvSpPr txBox="1"/>
+          <p:nvPr/>
+        </p:nvSpPr>
+        <p:spPr>
+          <a:xfrm>
+            <a:off x="353969" y="1898140"/>
+            <a:ext cx="1685077" cy="523220"/>
+          </a:xfrm>
+          <a:prstGeom prst="rect">
+            <a:avLst/>
+          </a:prstGeom>
+          <a:noFill/>
+        </p:spPr>
+        <p:txBody>
+          <a:bodyPr wrap="none" rtlCol="0">
+            <a:spAutoFit/>
           </a:bodyPr>
           <a:lstStyle/>
           <a:p>
-            <a:pPr marL="514350" lvl="0" indent="-514350">
-              <a:buFont typeface="+mj-lt"/>
-              <a:buAutoNum type="arabicPeriod"/>
-            </a:pPr>
-            <a:r>
-              <a:rPr lang="de-DE" dirty="0"/>
-              <a:t>Welche Filialen haben den größten/kleinsten Umsatz? </a:t>
-            </a:r>
-            <a:r>
-              <a:rPr lang="de-DE" i="1" dirty="0"/>
-              <a:t>(Verkäufe/Stunde, Kategorisierung der Filialen)</a:t>
-            </a:r>
-            <a:endParaRPr lang="de-DE" dirty="0"/>
-          </a:p>
-          <a:p>
-            <a:pPr marL="514350" lvl="0" indent="-514350">
-              <a:buFont typeface="+mj-lt"/>
-              <a:buAutoNum type="arabicPeriod"/>
-            </a:pPr>
-            <a:r>
-              <a:rPr lang="de-DE" dirty="0"/>
-              <a:t>Welche Produkte haben die größte/kleinste Marge? </a:t>
-            </a:r>
-            <a:r>
-              <a:rPr lang="de-DE" i="1" dirty="0"/>
-              <a:t>(Produktpreis, Kosten der Zutaten, Energieverbrauch, Herstellungsdauer)</a:t>
-            </a:r>
-            <a:endParaRPr lang="de-DE" dirty="0"/>
-          </a:p>
-          <a:p>
-            <a:pPr marL="514350" lvl="0" indent="-514350">
-              <a:buFont typeface="+mj-lt"/>
-              <a:buAutoNum type="arabicPeriod"/>
-            </a:pPr>
-            <a:r>
-              <a:rPr lang="de-DE" dirty="0"/>
-              <a:t>Welche Produkte haben in der Herstellung den größten/kleinsten Energieverbrauch? </a:t>
-            </a:r>
-            <a:r>
-              <a:rPr lang="de-DE" i="1" dirty="0"/>
-              <a:t>(Backdauer, Kühlung der Zutaten)</a:t>
-            </a:r>
-            <a:endParaRPr lang="de-DE" dirty="0"/>
-          </a:p>
-          <a:p>
-            <a:pPr marL="514350" lvl="0" indent="-514350">
-              <a:buFont typeface="+mj-lt"/>
-              <a:buAutoNum type="arabicPeriod"/>
-            </a:pPr>
-            <a:r>
-              <a:rPr lang="de-DE" dirty="0"/>
-              <a:t>Zu welchen Tageszeiten wird welche Produktkategorie an welchem Standort am meisten gekauft? (Verkäufe)</a:t>
-            </a:r>
-          </a:p>
-          <a:p>
-            <a:pPr marL="514350" lvl="0" indent="-514350">
-              <a:buFont typeface="+mj-lt"/>
-              <a:buAutoNum type="arabicPeriod"/>
-            </a:pPr>
-            <a:r>
-              <a:rPr lang="de-DE" dirty="0"/>
-              <a:t>Welche Produkte werden am meisten/am wenigsten verkauft?</a:t>
-            </a:r>
-          </a:p>
-          <a:p>
-            <a:pPr marL="514350" indent="-514350">
-              <a:buFont typeface="+mj-lt"/>
-              <a:buAutoNum type="arabicPeriod"/>
-            </a:pPr>
-            <a:r>
-              <a:rPr lang="de-DE" dirty="0"/>
-              <a:t>Welcher Verkäufer hat den größten durchschnittlichen Umsatz pro Verkauf?</a:t>
+            <a:r>
+              <a:rPr lang="de-DE" sz="2800" b="1" dirty="0"/>
+              <a:t>Mit SCDs</a:t>
+            </a:r>
+          </a:p>
+        </p:txBody>
+      </p:sp>
+      <p:pic>
+        <p:nvPicPr>
+          <p:cNvPr id="6" name="Grafik 5">
+            <a:extLst>
+              <a:ext uri="{FF2B5EF4-FFF2-40B4-BE49-F238E27FC236}">
+                <a16:creationId xmlns:a16="http://schemas.microsoft.com/office/drawing/2014/main" id="{0F138F20-0FD1-EAF0-ECB1-C944E3841B38}"/>
+              </a:ext>
+            </a:extLst>
+          </p:cNvPr>
+          <p:cNvPicPr>
+            <a:picLocks noChangeAspect="1"/>
+          </p:cNvPicPr>
+          <p:nvPr/>
+        </p:nvPicPr>
+        <p:blipFill>
+          <a:blip r:embed="rId3">
+            <a:extLst>
+              <a:ext uri="{28A0092B-C50C-407E-A947-70E740481C1C}">
+                <a14:useLocalDpi xmlns:a14="http://schemas.microsoft.com/office/drawing/2010/main" val="0"/>
+              </a:ext>
+            </a:extLst>
+          </a:blip>
+          <a:srcRect/>
+          <a:stretch/>
+        </p:blipFill>
+        <p:spPr>
+          <a:xfrm>
+            <a:off x="5641957" y="0"/>
+            <a:ext cx="4623435" cy="6858000"/>
+          </a:xfrm>
+          <a:prstGeom prst="rect">
+            <a:avLst/>
+          </a:prstGeom>
+        </p:spPr>
+      </p:pic>
+      <p:sp>
+        <p:nvSpPr>
+          <p:cNvPr id="9" name="Textfeld 8">
+            <a:extLst>
+              <a:ext uri="{FF2B5EF4-FFF2-40B4-BE49-F238E27FC236}">
+                <a16:creationId xmlns:a16="http://schemas.microsoft.com/office/drawing/2014/main" id="{7F4D9F21-EE0C-77EE-09C3-536CCB745FD0}"/>
+              </a:ext>
+            </a:extLst>
+          </p:cNvPr>
+          <p:cNvSpPr txBox="1"/>
+          <p:nvPr/>
+        </p:nvSpPr>
+        <p:spPr>
+          <a:xfrm>
+            <a:off x="239669" y="2960009"/>
+            <a:ext cx="3840026" cy="523220"/>
+          </a:xfrm>
+          <a:prstGeom prst="rect">
+            <a:avLst/>
+          </a:prstGeom>
+          <a:noFill/>
+        </p:spPr>
+        <p:txBody>
+          <a:bodyPr wrap="none" rtlCol="0">
+            <a:spAutoFit/>
+          </a:bodyPr>
+          <a:lstStyle/>
+          <a:p>
+            <a:r>
+              <a:rPr lang="de-DE" sz="1400" dirty="0"/>
+              <a:t>SCD0: Attribute werden automatisch generiert, </a:t>
+            </a:r>
+          </a:p>
+          <a:p>
+            <a:r>
+              <a:rPr lang="de-DE" sz="1400" dirty="0"/>
+              <a:t>daher keine Änderung notwendig</a:t>
+            </a:r>
+          </a:p>
+        </p:txBody>
+      </p:sp>
+      <p:sp>
+        <p:nvSpPr>
+          <p:cNvPr id="5" name="Textfeld 4">
+            <a:extLst>
+              <a:ext uri="{FF2B5EF4-FFF2-40B4-BE49-F238E27FC236}">
+                <a16:creationId xmlns:a16="http://schemas.microsoft.com/office/drawing/2014/main" id="{98AB6B8C-56F1-28E8-201C-1EA535B163C3}"/>
+              </a:ext>
+            </a:extLst>
+          </p:cNvPr>
+          <p:cNvSpPr txBox="1"/>
+          <p:nvPr/>
+        </p:nvSpPr>
+        <p:spPr>
+          <a:xfrm>
+            <a:off x="8997739" y="658574"/>
+            <a:ext cx="2900265" cy="738664"/>
+          </a:xfrm>
+          <a:prstGeom prst="rect">
+            <a:avLst/>
+          </a:prstGeom>
+          <a:noFill/>
+        </p:spPr>
+        <p:txBody>
+          <a:bodyPr wrap="square" rtlCol="0">
+            <a:spAutoFit/>
+          </a:bodyPr>
+          <a:lstStyle/>
+          <a:p>
+            <a:r>
+              <a:rPr lang="de-DE" sz="1400" dirty="0"/>
+              <a:t>SCD1: Es können Namensänderungen auftreten,</a:t>
+            </a:r>
+          </a:p>
+          <a:p>
+            <a:r>
+              <a:rPr lang="de-DE" sz="1400" dirty="0"/>
+              <a:t>Historisierung aber nicht relevant</a:t>
+            </a:r>
+          </a:p>
+        </p:txBody>
+      </p:sp>
+      <p:sp>
+        <p:nvSpPr>
+          <p:cNvPr id="8" name="Textfeld 7">
+            <a:extLst>
+              <a:ext uri="{FF2B5EF4-FFF2-40B4-BE49-F238E27FC236}">
+                <a16:creationId xmlns:a16="http://schemas.microsoft.com/office/drawing/2014/main" id="{BE82647E-DA08-904C-9686-78B17E1E2BF3}"/>
+              </a:ext>
+            </a:extLst>
+          </p:cNvPr>
+          <p:cNvSpPr txBox="1"/>
+          <p:nvPr/>
+        </p:nvSpPr>
+        <p:spPr>
+          <a:xfrm>
+            <a:off x="4820813" y="2742565"/>
+            <a:ext cx="2000611" cy="1384995"/>
+          </a:xfrm>
+          <a:prstGeom prst="rect">
+            <a:avLst/>
+          </a:prstGeom>
+          <a:noFill/>
+        </p:spPr>
+        <p:txBody>
+          <a:bodyPr wrap="square" rtlCol="0">
+            <a:spAutoFit/>
+          </a:bodyPr>
+          <a:lstStyle/>
+          <a:p>
+            <a:r>
+              <a:rPr lang="de-DE" sz="1400" dirty="0"/>
+              <a:t>SCD3: Der Filialname kann sich ändern, eher seltener Vorgang,</a:t>
+            </a:r>
+          </a:p>
+          <a:p>
+            <a:r>
+              <a:rPr lang="de-DE" sz="1400" dirty="0"/>
+              <a:t>Informationen über alten Namen trotzdem wichtig</a:t>
+            </a:r>
+          </a:p>
+        </p:txBody>
+      </p:sp>
+      <p:sp>
+        <p:nvSpPr>
+          <p:cNvPr id="11" name="Textfeld 10">
+            <a:extLst>
+              <a:ext uri="{FF2B5EF4-FFF2-40B4-BE49-F238E27FC236}">
+                <a16:creationId xmlns:a16="http://schemas.microsoft.com/office/drawing/2014/main" id="{97E9B84A-AE4B-9768-2853-76649DB47F25}"/>
+              </a:ext>
+            </a:extLst>
+          </p:cNvPr>
+          <p:cNvSpPr txBox="1"/>
+          <p:nvPr/>
+        </p:nvSpPr>
+        <p:spPr>
+          <a:xfrm>
+            <a:off x="5051249" y="5726779"/>
+            <a:ext cx="3068623" cy="954107"/>
+          </a:xfrm>
+          <a:prstGeom prst="rect">
+            <a:avLst/>
+          </a:prstGeom>
+          <a:noFill/>
+        </p:spPr>
+        <p:txBody>
+          <a:bodyPr wrap="square" rtlCol="0">
+            <a:spAutoFit/>
+          </a:bodyPr>
+          <a:lstStyle/>
+          <a:p>
+            <a:r>
+              <a:rPr lang="de-DE" sz="1400" dirty="0"/>
+              <a:t>SCD4: Produktattribute können sich aufgrund von Inflation etc. oft ändern,</a:t>
+            </a:r>
+          </a:p>
+          <a:p>
+            <a:r>
+              <a:rPr lang="de-DE" sz="1400" dirty="0"/>
+              <a:t>Historisierung ist für die Analyse sehr wichtig</a:t>
             </a:r>
           </a:p>
         </p:txBody>
@@ -4382,7 +4528,7 @@
     </p:spTree>
     <p:extLst>
       <p:ext uri="{BB962C8B-B14F-4D97-AF65-F5344CB8AC3E}">
-        <p14:creationId xmlns:p14="http://schemas.microsoft.com/office/powerpoint/2010/main" val="237497836"/>
+        <p14:creationId xmlns:p14="http://schemas.microsoft.com/office/powerpoint/2010/main" val="1190778878"/>
       </p:ext>
     </p:extLst>
   </p:cSld>
@@ -4414,7 +4560,7 @@
           <p:cNvPr id="2" name="Titel 1">
             <a:extLst>
               <a:ext uri="{FF2B5EF4-FFF2-40B4-BE49-F238E27FC236}">
-                <a16:creationId xmlns:a16="http://schemas.microsoft.com/office/drawing/2014/main" id="{325C50AD-AB12-3666-A634-324EE9A12F09}"/>
+                <a16:creationId xmlns:a16="http://schemas.microsoft.com/office/drawing/2014/main" id="{D7C2311D-E75B-2973-3E6F-0EB0FACB9F26}"/>
               </a:ext>
             </a:extLst>
           </p:cNvPr>
@@ -4431,55 +4577,261 @@
           <a:lstStyle/>
           <a:p>
             <a:r>
-              <a:rPr lang="de-DE" dirty="0" err="1"/>
-              <a:t>mER</a:t>
-            </a:r>
-            <a:endParaRPr lang="de-DE" dirty="0"/>
-          </a:p>
-        </p:txBody>
-      </p:sp>
-      <p:pic>
-        <p:nvPicPr>
-          <p:cNvPr id="5" name="Inhaltsplatzhalter 4">
-            <a:extLst>
-              <a:ext uri="{FF2B5EF4-FFF2-40B4-BE49-F238E27FC236}">
-                <a16:creationId xmlns:a16="http://schemas.microsoft.com/office/drawing/2014/main" id="{C599200D-D61C-1F8B-D3A1-5E8901654166}"/>
-              </a:ext>
-            </a:extLst>
-          </p:cNvPr>
-          <p:cNvPicPr>
-            <a:picLocks noGrp="1" noChangeAspect="1"/>
-          </p:cNvPicPr>
-          <p:nvPr>
-            <p:ph idx="1"/>
-          </p:nvPr>
-        </p:nvPicPr>
-        <p:blipFill>
-          <a:blip r:embed="rId3">
-            <a:extLst>
-              <a:ext uri="{28A0092B-C50C-407E-A947-70E740481C1C}">
-                <a14:useLocalDpi xmlns:a14="http://schemas.microsoft.com/office/drawing/2010/main" val="0"/>
-              </a:ext>
-            </a:extLst>
-          </a:blip>
-          <a:stretch>
-            <a:fillRect/>
-          </a:stretch>
-        </p:blipFill>
+              <a:rPr lang="de-DE" dirty="0"/>
+              <a:t>ETL – Schedule</a:t>
+            </a:r>
+          </a:p>
+        </p:txBody>
+      </p:sp>
+      <p:sp>
+        <p:nvSpPr>
+          <p:cNvPr id="4" name="Textfeld 3">
+            <a:extLst>
+              <a:ext uri="{FF2B5EF4-FFF2-40B4-BE49-F238E27FC236}">
+                <a16:creationId xmlns:a16="http://schemas.microsoft.com/office/drawing/2014/main" id="{C36A1A73-D613-125C-5B7B-46985C53CDA6}"/>
+              </a:ext>
+            </a:extLst>
+          </p:cNvPr>
+          <p:cNvSpPr txBox="1"/>
+          <p:nvPr/>
+        </p:nvSpPr>
         <p:spPr>
           <a:xfrm>
-            <a:off x="2617794" y="365125"/>
-            <a:ext cx="8736006" cy="5942782"/>
+            <a:off x="838200" y="1690688"/>
+            <a:ext cx="2259658" cy="369332"/>
           </a:xfrm>
           <a:prstGeom prst="rect">
             <a:avLst/>
           </a:prstGeom>
+          <a:noFill/>
         </p:spPr>
-      </p:pic>
+        <p:txBody>
+          <a:bodyPr wrap="none" rtlCol="0">
+            <a:spAutoFit/>
+          </a:bodyPr>
+          <a:lstStyle/>
+          <a:p>
+            <a:r>
+              <a:rPr lang="de-DE" u="sng" dirty="0"/>
+              <a:t>Dimension Verkäufer</a:t>
+            </a:r>
+          </a:p>
+        </p:txBody>
+      </p:sp>
+      <p:sp>
+        <p:nvSpPr>
+          <p:cNvPr id="6" name="Textfeld 5">
+            <a:extLst>
+              <a:ext uri="{FF2B5EF4-FFF2-40B4-BE49-F238E27FC236}">
+                <a16:creationId xmlns:a16="http://schemas.microsoft.com/office/drawing/2014/main" id="{17EF025E-B37F-0B25-14A6-A9D9F1278848}"/>
+              </a:ext>
+            </a:extLst>
+          </p:cNvPr>
+          <p:cNvSpPr txBox="1"/>
+          <p:nvPr/>
+        </p:nvSpPr>
+        <p:spPr>
+          <a:xfrm>
+            <a:off x="838200" y="2859858"/>
+            <a:ext cx="2944589" cy="369332"/>
+          </a:xfrm>
+          <a:prstGeom prst="rect">
+            <a:avLst/>
+          </a:prstGeom>
+          <a:noFill/>
+        </p:spPr>
+        <p:txBody>
+          <a:bodyPr wrap="none" rtlCol="0">
+            <a:spAutoFit/>
+          </a:bodyPr>
+          <a:lstStyle/>
+          <a:p>
+            <a:r>
+              <a:rPr lang="de-DE" u="sng" dirty="0"/>
+              <a:t>Dimension Verkaufsvorgang</a:t>
+            </a:r>
+          </a:p>
+        </p:txBody>
+      </p:sp>
+      <p:sp>
+        <p:nvSpPr>
+          <p:cNvPr id="8" name="Textfeld 7">
+            <a:extLst>
+              <a:ext uri="{FF2B5EF4-FFF2-40B4-BE49-F238E27FC236}">
+                <a16:creationId xmlns:a16="http://schemas.microsoft.com/office/drawing/2014/main" id="{9B3F62D3-5C4A-293E-DDC9-86D6DE180307}"/>
+              </a:ext>
+            </a:extLst>
+          </p:cNvPr>
+          <p:cNvSpPr txBox="1"/>
+          <p:nvPr/>
+        </p:nvSpPr>
+        <p:spPr>
+          <a:xfrm>
+            <a:off x="8763000" y="1506022"/>
+            <a:ext cx="1990545" cy="369332"/>
+          </a:xfrm>
+          <a:prstGeom prst="rect">
+            <a:avLst/>
+          </a:prstGeom>
+          <a:noFill/>
+        </p:spPr>
+        <p:txBody>
+          <a:bodyPr wrap="none" rtlCol="0">
+            <a:spAutoFit/>
+          </a:bodyPr>
+          <a:lstStyle/>
+          <a:p>
+            <a:r>
+              <a:rPr lang="de-DE" u="sng" dirty="0"/>
+              <a:t>Dimension Datum</a:t>
+            </a:r>
+          </a:p>
+        </p:txBody>
+      </p:sp>
+      <p:sp>
+        <p:nvSpPr>
+          <p:cNvPr id="10" name="Textfeld 9">
+            <a:extLst>
+              <a:ext uri="{FF2B5EF4-FFF2-40B4-BE49-F238E27FC236}">
+                <a16:creationId xmlns:a16="http://schemas.microsoft.com/office/drawing/2014/main" id="{D8D8EC8A-04C8-94DC-BC27-AB08E6F9504B}"/>
+              </a:ext>
+            </a:extLst>
+          </p:cNvPr>
+          <p:cNvSpPr txBox="1"/>
+          <p:nvPr/>
+        </p:nvSpPr>
+        <p:spPr>
+          <a:xfrm>
+            <a:off x="6312955" y="1069722"/>
+            <a:ext cx="1680268" cy="369332"/>
+          </a:xfrm>
+          <a:prstGeom prst="rect">
+            <a:avLst/>
+          </a:prstGeom>
+          <a:noFill/>
+        </p:spPr>
+        <p:txBody>
+          <a:bodyPr wrap="none" rtlCol="0">
+            <a:spAutoFit/>
+          </a:bodyPr>
+          <a:lstStyle/>
+          <a:p>
+            <a:r>
+              <a:rPr lang="de-DE" u="sng" dirty="0"/>
+              <a:t>Dimension Zeit</a:t>
+            </a:r>
+          </a:p>
+        </p:txBody>
+      </p:sp>
+      <p:sp>
+        <p:nvSpPr>
+          <p:cNvPr id="12" name="Textfeld 11">
+            <a:extLst>
+              <a:ext uri="{FF2B5EF4-FFF2-40B4-BE49-F238E27FC236}">
+                <a16:creationId xmlns:a16="http://schemas.microsoft.com/office/drawing/2014/main" id="{3DE37009-6E01-95A7-908C-6E3CB738357C}"/>
+              </a:ext>
+            </a:extLst>
+          </p:cNvPr>
+          <p:cNvSpPr txBox="1"/>
+          <p:nvPr/>
+        </p:nvSpPr>
+        <p:spPr>
+          <a:xfrm>
+            <a:off x="6108739" y="3244334"/>
+            <a:ext cx="1901226" cy="369332"/>
+          </a:xfrm>
+          <a:prstGeom prst="rect">
+            <a:avLst/>
+          </a:prstGeom>
+          <a:noFill/>
+        </p:spPr>
+        <p:txBody>
+          <a:bodyPr wrap="none" rtlCol="0">
+            <a:spAutoFit/>
+          </a:bodyPr>
+          <a:lstStyle/>
+          <a:p>
+            <a:r>
+              <a:rPr lang="de-DE" u="sng" dirty="0"/>
+              <a:t>Dimension Filiale</a:t>
+            </a:r>
+          </a:p>
+        </p:txBody>
+      </p:sp>
+      <p:sp>
+        <p:nvSpPr>
+          <p:cNvPr id="14" name="Textfeld 13">
+            <a:extLst>
+              <a:ext uri="{FF2B5EF4-FFF2-40B4-BE49-F238E27FC236}">
+                <a16:creationId xmlns:a16="http://schemas.microsoft.com/office/drawing/2014/main" id="{90F2C1CE-776F-E6F4-BA3D-39ABFEA8CCA9}"/>
+              </a:ext>
+            </a:extLst>
+          </p:cNvPr>
+          <p:cNvSpPr txBox="1"/>
+          <p:nvPr/>
+        </p:nvSpPr>
+        <p:spPr>
+          <a:xfrm>
+            <a:off x="1411224" y="4104299"/>
+            <a:ext cx="2085379" cy="369332"/>
+          </a:xfrm>
+          <a:prstGeom prst="rect">
+            <a:avLst/>
+          </a:prstGeom>
+          <a:noFill/>
+        </p:spPr>
+        <p:txBody>
+          <a:bodyPr wrap="none" rtlCol="0">
+            <a:spAutoFit/>
+          </a:bodyPr>
+          <a:lstStyle/>
+          <a:p>
+            <a:r>
+              <a:rPr lang="de-DE" u="sng" dirty="0"/>
+              <a:t>Dimension Produkt</a:t>
+            </a:r>
+          </a:p>
+        </p:txBody>
+      </p:sp>
+      <p:sp>
+        <p:nvSpPr>
+          <p:cNvPr id="16" name="Textfeld 15">
+            <a:extLst>
+              <a:ext uri="{FF2B5EF4-FFF2-40B4-BE49-F238E27FC236}">
+                <a16:creationId xmlns:a16="http://schemas.microsoft.com/office/drawing/2014/main" id="{8B669590-7EE9-E0EE-1719-D3F02D7D75F5}"/>
+              </a:ext>
+            </a:extLst>
+          </p:cNvPr>
+          <p:cNvSpPr txBox="1"/>
+          <p:nvPr/>
+        </p:nvSpPr>
+        <p:spPr>
+          <a:xfrm>
+            <a:off x="6169699" y="1378389"/>
+            <a:ext cx="2593301" cy="738664"/>
+          </a:xfrm>
+          <a:prstGeom prst="rect">
+            <a:avLst/>
+          </a:prstGeom>
+          <a:noFill/>
+        </p:spPr>
+        <p:txBody>
+          <a:bodyPr wrap="square" rtlCol="0">
+            <a:spAutoFit/>
+          </a:bodyPr>
+          <a:lstStyle/>
+          <a:p>
+            <a:r>
+              <a:rPr lang="de-DE" sz="1400" dirty="0"/>
+              <a:t>Wird vollständig zu Beginn angelegt und ändert sich dann nicht mehr</a:t>
+            </a:r>
+          </a:p>
+        </p:txBody>
+      </p:sp>
     </p:spTree>
     <p:extLst>
       <p:ext uri="{BB962C8B-B14F-4D97-AF65-F5344CB8AC3E}">
-        <p14:creationId xmlns:p14="http://schemas.microsoft.com/office/powerpoint/2010/main" val="427920151"/>
+        <p14:creationId xmlns:p14="http://schemas.microsoft.com/office/powerpoint/2010/main" val="4178603353"/>
       </p:ext>
     </p:extLst>
   </p:cSld>
@@ -4511,7 +4863,7 @@
           <p:cNvPr id="2" name="Titel 1">
             <a:extLst>
               <a:ext uri="{FF2B5EF4-FFF2-40B4-BE49-F238E27FC236}">
-                <a16:creationId xmlns:a16="http://schemas.microsoft.com/office/drawing/2014/main" id="{3904CDF3-4527-70B2-FABB-909DC6BA3CF1}"/>
+                <a16:creationId xmlns:a16="http://schemas.microsoft.com/office/drawing/2014/main" id="{F3530890-A338-17B9-45E2-17100BB72C32}"/>
               </a:ext>
             </a:extLst>
           </p:cNvPr>
@@ -4529,450 +4881,40 @@
           <a:p>
             <a:r>
               <a:rPr lang="de-DE" dirty="0"/>
-              <a:t>Logisches Modell</a:t>
-            </a:r>
-            <a:br>
-              <a:rPr lang="de-DE" dirty="0"/>
-            </a:br>
-            <a:r>
-              <a:rPr lang="de-DE" dirty="0"/>
-              <a:t>Galaxy Schema</a:t>
-            </a:r>
-          </a:p>
-        </p:txBody>
-      </p:sp>
-      <p:pic>
-        <p:nvPicPr>
-          <p:cNvPr id="5" name="Inhaltsplatzhalter 4">
-            <a:extLst>
-              <a:ext uri="{FF2B5EF4-FFF2-40B4-BE49-F238E27FC236}">
-                <a16:creationId xmlns:a16="http://schemas.microsoft.com/office/drawing/2014/main" id="{525D996C-32F6-0F32-53F9-94DC195EDD2E}"/>
-              </a:ext>
-            </a:extLst>
-          </p:cNvPr>
-          <p:cNvPicPr>
-            <a:picLocks noGrp="1" noChangeAspect="1"/>
-          </p:cNvPicPr>
+              <a:t>Highlights, Probleme und Ratschläge</a:t>
+            </a:r>
+          </a:p>
+        </p:txBody>
+      </p:sp>
+      <p:sp>
+        <p:nvSpPr>
+          <p:cNvPr id="3" name="Inhaltsplatzhalter 2">
+            <a:extLst>
+              <a:ext uri="{FF2B5EF4-FFF2-40B4-BE49-F238E27FC236}">
+                <a16:creationId xmlns:a16="http://schemas.microsoft.com/office/drawing/2014/main" id="{B40B26C1-8FAA-BDD3-23E1-57BAD8C574AC}"/>
+              </a:ext>
+            </a:extLst>
+          </p:cNvPr>
+          <p:cNvSpPr>
+            <a:spLocks noGrp="1"/>
+          </p:cNvSpPr>
           <p:nvPr>
             <p:ph idx="1"/>
           </p:nvPr>
-        </p:nvPicPr>
-        <p:blipFill>
-          <a:blip r:embed="rId3">
-            <a:extLst>
-              <a:ext uri="{28A0092B-C50C-407E-A947-70E740481C1C}">
-                <a14:useLocalDpi xmlns:a14="http://schemas.microsoft.com/office/drawing/2010/main" val="0"/>
-              </a:ext>
-            </a:extLst>
-          </a:blip>
-          <a:srcRect/>
-          <a:stretch/>
-        </p:blipFill>
-        <p:spPr>
-          <a:xfrm>
-            <a:off x="5155932" y="0"/>
-            <a:ext cx="5941996" cy="6727898"/>
-          </a:xfrm>
-          <a:prstGeom prst="rect">
-            <a:avLst/>
-          </a:prstGeom>
-        </p:spPr>
-      </p:pic>
+        </p:nvSpPr>
+        <p:spPr/>
+        <p:txBody>
+          <a:bodyPr/>
+          <a:lstStyle/>
+          <a:p>
+            <a:endParaRPr lang="de-DE"/>
+          </a:p>
+        </p:txBody>
+      </p:sp>
     </p:spTree>
     <p:extLst>
       <p:ext uri="{BB962C8B-B14F-4D97-AF65-F5344CB8AC3E}">
-        <p14:creationId xmlns:p14="http://schemas.microsoft.com/office/powerpoint/2010/main" val="763179585"/>
-      </p:ext>
-    </p:extLst>
-  </p:cSld>
-  <p:clrMapOvr>
-    <a:masterClrMapping/>
-  </p:clrMapOvr>
-</p:sld>
-</file>
-
-<file path=ppt/slides/slide13.xml><?xml version="1.0" encoding="utf-8"?>
-<p:sld xmlns:a="http://schemas.openxmlformats.org/drawingml/2006/main" xmlns:r="http://schemas.openxmlformats.org/officeDocument/2006/relationships" xmlns:p="http://schemas.openxmlformats.org/presentationml/2006/main">
-  <p:cSld>
-    <p:spTree>
-      <p:nvGrpSpPr>
-        <p:cNvPr id="1" name="">
-          <a:extLst>
-            <a:ext uri="{FF2B5EF4-FFF2-40B4-BE49-F238E27FC236}">
-              <a16:creationId xmlns:a16="http://schemas.microsoft.com/office/drawing/2014/main" id="{B0A518B4-6F6D-629A-78BB-C72612DF9CCA}"/>
-            </a:ext>
-          </a:extLst>
-        </p:cNvPr>
-        <p:cNvGrpSpPr/>
-        <p:nvPr/>
-      </p:nvGrpSpPr>
-      <p:grpSpPr>
-        <a:xfrm>
-          <a:off x="0" y="0"/>
-          <a:ext cx="0" cy="0"/>
-          <a:chOff x="0" y="0"/>
-          <a:chExt cx="0" cy="0"/>
-        </a:xfrm>
-      </p:grpSpPr>
-      <p:sp>
-        <p:nvSpPr>
-          <p:cNvPr id="2" name="Titel 1">
-            <a:extLst>
-              <a:ext uri="{FF2B5EF4-FFF2-40B4-BE49-F238E27FC236}">
-                <a16:creationId xmlns:a16="http://schemas.microsoft.com/office/drawing/2014/main" id="{381B224B-06D3-B13F-1F18-6E1D0094E5FF}"/>
-              </a:ext>
-            </a:extLst>
-          </p:cNvPr>
-          <p:cNvSpPr>
-            <a:spLocks noGrp="1"/>
-          </p:cNvSpPr>
-          <p:nvPr>
-            <p:ph type="title"/>
-          </p:nvPr>
-        </p:nvSpPr>
-        <p:spPr/>
-        <p:txBody>
-          <a:bodyPr/>
-          <a:lstStyle/>
-          <a:p>
-            <a:r>
-              <a:rPr lang="de-DE" dirty="0"/>
-              <a:t>Logisches Modell</a:t>
-            </a:r>
-            <a:br>
-              <a:rPr lang="de-DE" dirty="0"/>
-            </a:br>
-            <a:r>
-              <a:rPr lang="de-DE" dirty="0"/>
-              <a:t>Galaxy Schema</a:t>
-            </a:r>
-          </a:p>
-        </p:txBody>
-      </p:sp>
-      <p:sp>
-        <p:nvSpPr>
-          <p:cNvPr id="3" name="Textfeld 2">
-            <a:extLst>
-              <a:ext uri="{FF2B5EF4-FFF2-40B4-BE49-F238E27FC236}">
-                <a16:creationId xmlns:a16="http://schemas.microsoft.com/office/drawing/2014/main" id="{91E45CDD-F47D-7F96-C9A6-A43E20426182}"/>
-              </a:ext>
-            </a:extLst>
-          </p:cNvPr>
-          <p:cNvSpPr txBox="1"/>
-          <p:nvPr/>
-        </p:nvSpPr>
-        <p:spPr>
-          <a:xfrm>
-            <a:off x="353969" y="1898140"/>
-            <a:ext cx="1685077" cy="523220"/>
-          </a:xfrm>
-          <a:prstGeom prst="rect">
-            <a:avLst/>
-          </a:prstGeom>
-          <a:noFill/>
-        </p:spPr>
-        <p:txBody>
-          <a:bodyPr wrap="none" rtlCol="0">
-            <a:spAutoFit/>
-          </a:bodyPr>
-          <a:lstStyle/>
-          <a:p>
-            <a:r>
-              <a:rPr lang="de-DE" sz="2800" b="1" dirty="0"/>
-              <a:t>Mit SCDs</a:t>
-            </a:r>
-          </a:p>
-        </p:txBody>
-      </p:sp>
-      <p:pic>
-        <p:nvPicPr>
-          <p:cNvPr id="6" name="Grafik 5">
-            <a:extLst>
-              <a:ext uri="{FF2B5EF4-FFF2-40B4-BE49-F238E27FC236}">
-                <a16:creationId xmlns:a16="http://schemas.microsoft.com/office/drawing/2014/main" id="{0F138F20-0FD1-EAF0-ECB1-C944E3841B38}"/>
-              </a:ext>
-            </a:extLst>
-          </p:cNvPr>
-          <p:cNvPicPr>
-            <a:picLocks noChangeAspect="1"/>
-          </p:cNvPicPr>
-          <p:nvPr/>
-        </p:nvPicPr>
-        <p:blipFill>
-          <a:blip r:embed="rId3">
-            <a:extLst>
-              <a:ext uri="{28A0092B-C50C-407E-A947-70E740481C1C}">
-                <a14:useLocalDpi xmlns:a14="http://schemas.microsoft.com/office/drawing/2010/main" val="0"/>
-              </a:ext>
-            </a:extLst>
-          </a:blip>
-          <a:srcRect/>
-          <a:stretch/>
-        </p:blipFill>
-        <p:spPr>
-          <a:xfrm>
-            <a:off x="5641957" y="0"/>
-            <a:ext cx="4623435" cy="6858000"/>
-          </a:xfrm>
-          <a:prstGeom prst="rect">
-            <a:avLst/>
-          </a:prstGeom>
-        </p:spPr>
-      </p:pic>
-      <p:sp>
-        <p:nvSpPr>
-          <p:cNvPr id="9" name="Textfeld 8">
-            <a:extLst>
-              <a:ext uri="{FF2B5EF4-FFF2-40B4-BE49-F238E27FC236}">
-                <a16:creationId xmlns:a16="http://schemas.microsoft.com/office/drawing/2014/main" id="{7F4D9F21-EE0C-77EE-09C3-536CCB745FD0}"/>
-              </a:ext>
-            </a:extLst>
-          </p:cNvPr>
-          <p:cNvSpPr txBox="1"/>
-          <p:nvPr/>
-        </p:nvSpPr>
-        <p:spPr>
-          <a:xfrm>
-            <a:off x="239669" y="2960009"/>
-            <a:ext cx="3840026" cy="523220"/>
-          </a:xfrm>
-          <a:prstGeom prst="rect">
-            <a:avLst/>
-          </a:prstGeom>
-          <a:noFill/>
-        </p:spPr>
-        <p:txBody>
-          <a:bodyPr wrap="none" rtlCol="0">
-            <a:spAutoFit/>
-          </a:bodyPr>
-          <a:lstStyle/>
-          <a:p>
-            <a:r>
-              <a:rPr lang="de-DE" sz="1400" dirty="0"/>
-              <a:t>SCD0: Attribute werden automatisch generiert, </a:t>
-            </a:r>
-          </a:p>
-          <a:p>
-            <a:r>
-              <a:rPr lang="de-DE" sz="1400" dirty="0"/>
-              <a:t>daher keine Änderung notwendig</a:t>
-            </a:r>
-          </a:p>
-        </p:txBody>
-      </p:sp>
-      <p:sp>
-        <p:nvSpPr>
-          <p:cNvPr id="5" name="Textfeld 4">
-            <a:extLst>
-              <a:ext uri="{FF2B5EF4-FFF2-40B4-BE49-F238E27FC236}">
-                <a16:creationId xmlns:a16="http://schemas.microsoft.com/office/drawing/2014/main" id="{98AB6B8C-56F1-28E8-201C-1EA535B163C3}"/>
-              </a:ext>
-            </a:extLst>
-          </p:cNvPr>
-          <p:cNvSpPr txBox="1"/>
-          <p:nvPr/>
-        </p:nvSpPr>
-        <p:spPr>
-          <a:xfrm>
-            <a:off x="8997739" y="658574"/>
-            <a:ext cx="2900265" cy="738664"/>
-          </a:xfrm>
-          <a:prstGeom prst="rect">
-            <a:avLst/>
-          </a:prstGeom>
-          <a:noFill/>
-        </p:spPr>
-        <p:txBody>
-          <a:bodyPr wrap="square" rtlCol="0">
-            <a:spAutoFit/>
-          </a:bodyPr>
-          <a:lstStyle/>
-          <a:p>
-            <a:r>
-              <a:rPr lang="de-DE" sz="1400" dirty="0"/>
-              <a:t>SCD1: Es können Namensänderungen auftreten,</a:t>
-            </a:r>
-          </a:p>
-          <a:p>
-            <a:r>
-              <a:rPr lang="de-DE" sz="1400" dirty="0"/>
-              <a:t>Historisierung aber nicht relevant</a:t>
-            </a:r>
-          </a:p>
-        </p:txBody>
-      </p:sp>
-      <p:sp>
-        <p:nvSpPr>
-          <p:cNvPr id="8" name="Textfeld 7">
-            <a:extLst>
-              <a:ext uri="{FF2B5EF4-FFF2-40B4-BE49-F238E27FC236}">
-                <a16:creationId xmlns:a16="http://schemas.microsoft.com/office/drawing/2014/main" id="{BE82647E-DA08-904C-9686-78B17E1E2BF3}"/>
-              </a:ext>
-            </a:extLst>
-          </p:cNvPr>
-          <p:cNvSpPr txBox="1"/>
-          <p:nvPr/>
-        </p:nvSpPr>
-        <p:spPr>
-          <a:xfrm>
-            <a:off x="4820813" y="2742565"/>
-            <a:ext cx="2000611" cy="1384995"/>
-          </a:xfrm>
-          <a:prstGeom prst="rect">
-            <a:avLst/>
-          </a:prstGeom>
-          <a:noFill/>
-        </p:spPr>
-        <p:txBody>
-          <a:bodyPr wrap="square" rtlCol="0">
-            <a:spAutoFit/>
-          </a:bodyPr>
-          <a:lstStyle/>
-          <a:p>
-            <a:r>
-              <a:rPr lang="de-DE" sz="1400" dirty="0"/>
-              <a:t>SCD3: Der Filialname kann sich ändern, eher seltener Vorgang,</a:t>
-            </a:r>
-          </a:p>
-          <a:p>
-            <a:r>
-              <a:rPr lang="de-DE" sz="1400" dirty="0"/>
-              <a:t>Informationen über alten Namen trotzdem wichtig</a:t>
-            </a:r>
-          </a:p>
-        </p:txBody>
-      </p:sp>
-      <p:sp>
-        <p:nvSpPr>
-          <p:cNvPr id="11" name="Textfeld 10">
-            <a:extLst>
-              <a:ext uri="{FF2B5EF4-FFF2-40B4-BE49-F238E27FC236}">
-                <a16:creationId xmlns:a16="http://schemas.microsoft.com/office/drawing/2014/main" id="{97E9B84A-AE4B-9768-2853-76649DB47F25}"/>
-              </a:ext>
-            </a:extLst>
-          </p:cNvPr>
-          <p:cNvSpPr txBox="1"/>
-          <p:nvPr/>
-        </p:nvSpPr>
-        <p:spPr>
-          <a:xfrm>
-            <a:off x="5051249" y="5726779"/>
-            <a:ext cx="3068623" cy="954107"/>
-          </a:xfrm>
-          <a:prstGeom prst="rect">
-            <a:avLst/>
-          </a:prstGeom>
-          <a:noFill/>
-        </p:spPr>
-        <p:txBody>
-          <a:bodyPr wrap="square" rtlCol="0">
-            <a:spAutoFit/>
-          </a:bodyPr>
-          <a:lstStyle/>
-          <a:p>
-            <a:r>
-              <a:rPr lang="de-DE" sz="1400" dirty="0"/>
-              <a:t>SCD4: Produktattribute können sich aufgrund von Inflation etc. oft ändern,</a:t>
-            </a:r>
-          </a:p>
-          <a:p>
-            <a:r>
-              <a:rPr lang="de-DE" sz="1400" dirty="0"/>
-              <a:t>Historisierung ist für die Analyse sehr wichtig</a:t>
-            </a:r>
-          </a:p>
-        </p:txBody>
-      </p:sp>
-    </p:spTree>
-    <p:extLst>
-      <p:ext uri="{BB962C8B-B14F-4D97-AF65-F5344CB8AC3E}">
-        <p14:creationId xmlns:p14="http://schemas.microsoft.com/office/powerpoint/2010/main" val="1190778878"/>
-      </p:ext>
-    </p:extLst>
-  </p:cSld>
-  <p:clrMapOvr>
-    <a:masterClrMapping/>
-  </p:clrMapOvr>
-</p:sld>
-</file>
-
-<file path=ppt/slides/slide14.xml><?xml version="1.0" encoding="utf-8"?>
-<p:sld xmlns:a="http://schemas.openxmlformats.org/drawingml/2006/main" xmlns:r="http://schemas.openxmlformats.org/officeDocument/2006/relationships" xmlns:p="http://schemas.openxmlformats.org/presentationml/2006/main">
-  <p:cSld>
-    <p:spTree>
-      <p:nvGrpSpPr>
-        <p:cNvPr id="1" name=""/>
-        <p:cNvGrpSpPr/>
-        <p:nvPr/>
-      </p:nvGrpSpPr>
-      <p:grpSpPr>
-        <a:xfrm>
-          <a:off x="0" y="0"/>
-          <a:ext cx="0" cy="0"/>
-          <a:chOff x="0" y="0"/>
-          <a:chExt cx="0" cy="0"/>
-        </a:xfrm>
-      </p:grpSpPr>
-      <p:sp>
-        <p:nvSpPr>
-          <p:cNvPr id="2" name="Titel 1">
-            <a:extLst>
-              <a:ext uri="{FF2B5EF4-FFF2-40B4-BE49-F238E27FC236}">
-                <a16:creationId xmlns:a16="http://schemas.microsoft.com/office/drawing/2014/main" id="{D7C2311D-E75B-2973-3E6F-0EB0FACB9F26}"/>
-              </a:ext>
-            </a:extLst>
-          </p:cNvPr>
-          <p:cNvSpPr>
-            <a:spLocks noGrp="1"/>
-          </p:cNvSpPr>
-          <p:nvPr>
-            <p:ph type="title"/>
-          </p:nvPr>
-        </p:nvSpPr>
-        <p:spPr/>
-        <p:txBody>
-          <a:bodyPr/>
-          <a:lstStyle/>
-          <a:p>
-            <a:r>
-              <a:rPr lang="de-DE" dirty="0"/>
-              <a:t>ETL – Mapping Tabelle</a:t>
-            </a:r>
-          </a:p>
-        </p:txBody>
-      </p:sp>
-      <p:sp>
-        <p:nvSpPr>
-          <p:cNvPr id="3" name="Inhaltsplatzhalter 2">
-            <a:extLst>
-              <a:ext uri="{FF2B5EF4-FFF2-40B4-BE49-F238E27FC236}">
-                <a16:creationId xmlns:a16="http://schemas.microsoft.com/office/drawing/2014/main" id="{6C270558-67B5-2E63-161E-DB5D3489FD15}"/>
-              </a:ext>
-            </a:extLst>
-          </p:cNvPr>
-          <p:cNvSpPr>
-            <a:spLocks noGrp="1"/>
-          </p:cNvSpPr>
-          <p:nvPr>
-            <p:ph idx="1"/>
-          </p:nvPr>
-        </p:nvSpPr>
-        <p:spPr/>
-        <p:txBody>
-          <a:bodyPr/>
-          <a:lstStyle/>
-          <a:p>
-            <a:r>
-              <a:rPr lang="de-DE" dirty="0"/>
-              <a:t>Wesentliche Erkenntnisse:</a:t>
-            </a:r>
-          </a:p>
-        </p:txBody>
-      </p:sp>
-    </p:spTree>
-    <p:extLst>
-      <p:ext uri="{BB962C8B-B14F-4D97-AF65-F5344CB8AC3E}">
-        <p14:creationId xmlns:p14="http://schemas.microsoft.com/office/powerpoint/2010/main" val="4178603353"/>
+        <p14:creationId xmlns:p14="http://schemas.microsoft.com/office/powerpoint/2010/main" val="2784786867"/>
       </p:ext>
     </p:extLst>
   </p:cSld>
@@ -5449,10 +5391,10 @@
       </p:grpSpPr>
       <p:sp>
         <p:nvSpPr>
-          <p:cNvPr id="2" name="Titel 1">
-            <a:extLst>
-              <a:ext uri="{FF2B5EF4-FFF2-40B4-BE49-F238E27FC236}">
-                <a16:creationId xmlns:a16="http://schemas.microsoft.com/office/drawing/2014/main" id="{2847A2DD-B513-9CAE-097B-46D56B639D2B}"/>
+          <p:cNvPr id="4" name="Titel 3">
+            <a:extLst>
+              <a:ext uri="{FF2B5EF4-FFF2-40B4-BE49-F238E27FC236}">
+                <a16:creationId xmlns:a16="http://schemas.microsoft.com/office/drawing/2014/main" id="{D8BBB4D9-AB0A-37B6-B9D7-67AEE8951BA2}"/>
               </a:ext>
             </a:extLst>
           </p:cNvPr>
@@ -5470,25 +5412,25 @@
           <a:p>
             <a:r>
               <a:rPr lang="de-DE" dirty="0"/>
-              <a:t>Relationales Schema</a:t>
-            </a:r>
-          </a:p>
-        </p:txBody>
-      </p:sp>
-      <p:sp>
-        <p:nvSpPr>
-          <p:cNvPr id="3" name="Inhaltsplatzhalter 2">
-            <a:extLst>
-              <a:ext uri="{FF2B5EF4-FFF2-40B4-BE49-F238E27FC236}">
-                <a16:creationId xmlns:a16="http://schemas.microsoft.com/office/drawing/2014/main" id="{637DD96A-1D7C-AE1B-9BBA-C416AC28B2AF}"/>
-              </a:ext>
-            </a:extLst>
-          </p:cNvPr>
-          <p:cNvSpPr>
-            <a:spLocks noGrp="1"/>
-          </p:cNvSpPr>
-          <p:nvPr>
-            <p:ph idx="1"/>
+              <a:t>Data Warehouse</a:t>
+            </a:r>
+          </a:p>
+        </p:txBody>
+      </p:sp>
+      <p:sp>
+        <p:nvSpPr>
+          <p:cNvPr id="5" name="Textplatzhalter 4">
+            <a:extLst>
+              <a:ext uri="{FF2B5EF4-FFF2-40B4-BE49-F238E27FC236}">
+                <a16:creationId xmlns:a16="http://schemas.microsoft.com/office/drawing/2014/main" id="{DDD8E57D-6B19-DF39-2489-BEAA298E6F36}"/>
+              </a:ext>
+            </a:extLst>
+          </p:cNvPr>
+          <p:cNvSpPr>
+            <a:spLocks noGrp="1"/>
+          </p:cNvSpPr>
+          <p:nvPr>
+            <p:ph type="body" idx="1"/>
           </p:nvPr>
         </p:nvSpPr>
         <p:spPr/>
@@ -5503,7 +5445,7 @@
     </p:spTree>
     <p:extLst>
       <p:ext uri="{BB962C8B-B14F-4D97-AF65-F5344CB8AC3E}">
-        <p14:creationId xmlns:p14="http://schemas.microsoft.com/office/powerpoint/2010/main" val="3813430610"/>
+        <p14:creationId xmlns:p14="http://schemas.microsoft.com/office/powerpoint/2010/main" val="2824883227"/>
       </p:ext>
     </p:extLst>
   </p:cSld>
@@ -5532,10 +5474,10 @@
       </p:grpSpPr>
       <p:sp>
         <p:nvSpPr>
-          <p:cNvPr id="2" name="Titel 1">
-            <a:extLst>
-              <a:ext uri="{FF2B5EF4-FFF2-40B4-BE49-F238E27FC236}">
-                <a16:creationId xmlns:a16="http://schemas.microsoft.com/office/drawing/2014/main" id="{C03FD591-FEFE-C790-E324-95CC3715A429}"/>
+          <p:cNvPr id="4" name="Titel 3">
+            <a:extLst>
+              <a:ext uri="{FF2B5EF4-FFF2-40B4-BE49-F238E27FC236}">
+                <a16:creationId xmlns:a16="http://schemas.microsoft.com/office/drawing/2014/main" id="{7FBC5EB2-8E38-A6FF-3747-7C0FBA075449}"/>
               </a:ext>
             </a:extLst>
           </p:cNvPr>
@@ -5553,17 +5495,17 @@
           <a:p>
             <a:r>
               <a:rPr lang="de-DE" dirty="0"/>
-              <a:t>Normalform-Überprüfung</a:t>
-            </a:r>
-          </a:p>
-        </p:txBody>
-      </p:sp>
-      <p:sp>
-        <p:nvSpPr>
-          <p:cNvPr id="3" name="Inhaltsplatzhalter 2">
-            <a:extLst>
-              <a:ext uri="{FF2B5EF4-FFF2-40B4-BE49-F238E27FC236}">
-                <a16:creationId xmlns:a16="http://schemas.microsoft.com/office/drawing/2014/main" id="{5967946A-B62B-A3C9-3EA7-AD8272504AA7}"/>
+              <a:t>DWH-Fragen</a:t>
+            </a:r>
+          </a:p>
+        </p:txBody>
+      </p:sp>
+      <p:sp>
+        <p:nvSpPr>
+          <p:cNvPr id="5" name="Inhaltsplatzhalter 4">
+            <a:extLst>
+              <a:ext uri="{FF2B5EF4-FFF2-40B4-BE49-F238E27FC236}">
+                <a16:creationId xmlns:a16="http://schemas.microsoft.com/office/drawing/2014/main" id="{CE1C7ED1-A131-55DE-7840-35E53E3E2D37}"/>
               </a:ext>
             </a:extLst>
           </p:cNvPr>
@@ -5576,17 +5518,91 @@
         </p:nvSpPr>
         <p:spPr/>
         <p:txBody>
-          <a:bodyPr/>
-          <a:lstStyle/>
-          <a:p>
-            <a:endParaRPr lang="de-DE"/>
+          <a:bodyPr>
+            <a:normAutofit fontScale="92500" lnSpcReduction="10000"/>
+          </a:bodyPr>
+          <a:lstStyle/>
+          <a:p>
+            <a:pPr marL="514350" lvl="0" indent="-514350">
+              <a:buFont typeface="+mj-lt"/>
+              <a:buAutoNum type="arabicPeriod"/>
+            </a:pPr>
+            <a:r>
+              <a:rPr lang="de-DE" dirty="0"/>
+              <a:t>Welche Filialen haben den größten/kleinsten Umsatz? </a:t>
+            </a:r>
+            <a:r>
+              <a:rPr lang="de-DE" i="1" dirty="0"/>
+              <a:t>(Verkäufe/Stunde, Kategorisierung der Filialen)</a:t>
+            </a:r>
+            <a:endParaRPr lang="de-DE" dirty="0"/>
+          </a:p>
+          <a:p>
+            <a:pPr marL="514350" lvl="0" indent="-514350">
+              <a:buFont typeface="+mj-lt"/>
+              <a:buAutoNum type="arabicPeriod"/>
+            </a:pPr>
+            <a:r>
+              <a:rPr lang="de-DE" dirty="0"/>
+              <a:t>Welche Produkte haben die größte/kleinste Marge? </a:t>
+            </a:r>
+            <a:r>
+              <a:rPr lang="de-DE" i="1" dirty="0"/>
+              <a:t>(Produktpreis, Kosten der Zutaten, Energieverbrauch, Herstellungsdauer)</a:t>
+            </a:r>
+            <a:endParaRPr lang="de-DE" dirty="0"/>
+          </a:p>
+          <a:p>
+            <a:pPr marL="514350" lvl="0" indent="-514350">
+              <a:buFont typeface="+mj-lt"/>
+              <a:buAutoNum type="arabicPeriod"/>
+            </a:pPr>
+            <a:r>
+              <a:rPr lang="de-DE" dirty="0"/>
+              <a:t>Welche Produkte haben in der Herstellung den größten/kleinsten Energieverbrauch? </a:t>
+            </a:r>
+            <a:r>
+              <a:rPr lang="de-DE" i="1" dirty="0"/>
+              <a:t>(Backdauer, Kühlung der Zutaten)</a:t>
+            </a:r>
+            <a:endParaRPr lang="de-DE" dirty="0"/>
+          </a:p>
+          <a:p>
+            <a:pPr marL="514350" lvl="0" indent="-514350">
+              <a:buFont typeface="+mj-lt"/>
+              <a:buAutoNum type="arabicPeriod"/>
+            </a:pPr>
+            <a:r>
+              <a:rPr lang="de-DE" dirty="0"/>
+              <a:t>Zu welchen Tageszeiten wird welche Produktkategorie an welchem Standort am meisten gekauft? (Verkäufe)</a:t>
+            </a:r>
+          </a:p>
+          <a:p>
+            <a:pPr marL="514350" lvl="0" indent="-514350">
+              <a:buFont typeface="+mj-lt"/>
+              <a:buAutoNum type="arabicPeriod"/>
+            </a:pPr>
+            <a:r>
+              <a:rPr lang="de-DE" dirty="0"/>
+              <a:t>Welche Produkte werden am meisten/am wenigsten verkauft?</a:t>
+            </a:r>
+          </a:p>
+          <a:p>
+            <a:pPr marL="514350" indent="-514350">
+              <a:buFont typeface="+mj-lt"/>
+              <a:buAutoNum type="arabicPeriod"/>
+            </a:pPr>
+            <a:r>
+              <a:rPr lang="de-DE" dirty="0"/>
+              <a:t>Welcher Verkäufer hat den größten durchschnittlichen Umsatz pro Verkauf?</a:t>
+            </a:r>
           </a:p>
         </p:txBody>
       </p:sp>
     </p:spTree>
     <p:extLst>
       <p:ext uri="{BB962C8B-B14F-4D97-AF65-F5344CB8AC3E}">
-        <p14:creationId xmlns:p14="http://schemas.microsoft.com/office/powerpoint/2010/main" val="1059657918"/>
+        <p14:creationId xmlns:p14="http://schemas.microsoft.com/office/powerpoint/2010/main" val="237497836"/>
       </p:ext>
     </p:extLst>
   </p:cSld>
@@ -5618,7 +5634,7 @@
           <p:cNvPr id="2" name="Titel 1">
             <a:extLst>
               <a:ext uri="{FF2B5EF4-FFF2-40B4-BE49-F238E27FC236}">
-                <a16:creationId xmlns:a16="http://schemas.microsoft.com/office/drawing/2014/main" id="{50205810-A1A2-AAB5-2E5A-B46F5FB3BEE9}"/>
+                <a16:creationId xmlns:a16="http://schemas.microsoft.com/office/drawing/2014/main" id="{325C50AD-AB12-3666-A634-324EE9A12F09}"/>
               </a:ext>
             </a:extLst>
           </p:cNvPr>
@@ -5635,41 +5651,55 @@
           <a:lstStyle/>
           <a:p>
             <a:r>
-              <a:rPr lang="de-DE" dirty="0"/>
-              <a:t>Speicherplatzberechnung</a:t>
-            </a:r>
-          </a:p>
-        </p:txBody>
-      </p:sp>
-      <p:sp>
-        <p:nvSpPr>
-          <p:cNvPr id="3" name="Inhaltsplatzhalter 2">
-            <a:extLst>
-              <a:ext uri="{FF2B5EF4-FFF2-40B4-BE49-F238E27FC236}">
-                <a16:creationId xmlns:a16="http://schemas.microsoft.com/office/drawing/2014/main" id="{AB6C21D1-2921-2860-E730-7DB0FD765F5E}"/>
-              </a:ext>
-            </a:extLst>
-          </p:cNvPr>
-          <p:cNvSpPr>
-            <a:spLocks noGrp="1"/>
-          </p:cNvSpPr>
+              <a:rPr lang="de-DE" dirty="0" err="1"/>
+              <a:t>mER</a:t>
+            </a:r>
+            <a:endParaRPr lang="de-DE" dirty="0"/>
+          </a:p>
+        </p:txBody>
+      </p:sp>
+      <p:pic>
+        <p:nvPicPr>
+          <p:cNvPr id="5" name="Inhaltsplatzhalter 4">
+            <a:extLst>
+              <a:ext uri="{FF2B5EF4-FFF2-40B4-BE49-F238E27FC236}">
+                <a16:creationId xmlns:a16="http://schemas.microsoft.com/office/drawing/2014/main" id="{C599200D-D61C-1F8B-D3A1-5E8901654166}"/>
+              </a:ext>
+            </a:extLst>
+          </p:cNvPr>
+          <p:cNvPicPr>
+            <a:picLocks noGrp="1" noChangeAspect="1"/>
+          </p:cNvPicPr>
           <p:nvPr>
             <p:ph idx="1"/>
           </p:nvPr>
-        </p:nvSpPr>
-        <p:spPr/>
-        <p:txBody>
-          <a:bodyPr/>
-          <a:lstStyle/>
-          <a:p>
-            <a:endParaRPr lang="de-DE"/>
-          </a:p>
-        </p:txBody>
-      </p:sp>
+        </p:nvPicPr>
+        <p:blipFill>
+          <a:blip r:embed="rId3">
+            <a:extLst>
+              <a:ext uri="{28A0092B-C50C-407E-A947-70E740481C1C}">
+                <a14:useLocalDpi xmlns:a14="http://schemas.microsoft.com/office/drawing/2010/main" val="0"/>
+              </a:ext>
+            </a:extLst>
+          </a:blip>
+          <a:stretch>
+            <a:fillRect/>
+          </a:stretch>
+        </p:blipFill>
+        <p:spPr>
+          <a:xfrm>
+            <a:off x="2617794" y="365125"/>
+            <a:ext cx="8736006" cy="5942782"/>
+          </a:xfrm>
+          <a:prstGeom prst="rect">
+            <a:avLst/>
+          </a:prstGeom>
+        </p:spPr>
+      </p:pic>
     </p:spTree>
     <p:extLst>
       <p:ext uri="{BB962C8B-B14F-4D97-AF65-F5344CB8AC3E}">
-        <p14:creationId xmlns:p14="http://schemas.microsoft.com/office/powerpoint/2010/main" val="86204701"/>
+        <p14:creationId xmlns:p14="http://schemas.microsoft.com/office/powerpoint/2010/main" val="427920151"/>
       </p:ext>
     </p:extLst>
   </p:cSld>
@@ -5698,10 +5728,10 @@
       </p:grpSpPr>
       <p:sp>
         <p:nvSpPr>
-          <p:cNvPr id="4" name="Titel 3">
-            <a:extLst>
-              <a:ext uri="{FF2B5EF4-FFF2-40B4-BE49-F238E27FC236}">
-                <a16:creationId xmlns:a16="http://schemas.microsoft.com/office/drawing/2014/main" id="{D8BBB4D9-AB0A-37B6-B9D7-67AEE8951BA2}"/>
+          <p:cNvPr id="2" name="Titel 1">
+            <a:extLst>
+              <a:ext uri="{FF2B5EF4-FFF2-40B4-BE49-F238E27FC236}">
+                <a16:creationId xmlns:a16="http://schemas.microsoft.com/office/drawing/2014/main" id="{3904CDF3-4527-70B2-FABB-909DC6BA3CF1}"/>
               </a:ext>
             </a:extLst>
           </p:cNvPr>
@@ -5719,40 +5749,59 @@
           <a:p>
             <a:r>
               <a:rPr lang="de-DE" dirty="0"/>
-              <a:t>Data Warehouse</a:t>
-            </a:r>
-          </a:p>
-        </p:txBody>
-      </p:sp>
-      <p:sp>
-        <p:nvSpPr>
-          <p:cNvPr id="5" name="Textplatzhalter 4">
-            <a:extLst>
-              <a:ext uri="{FF2B5EF4-FFF2-40B4-BE49-F238E27FC236}">
-                <a16:creationId xmlns:a16="http://schemas.microsoft.com/office/drawing/2014/main" id="{DDD8E57D-6B19-DF39-2489-BEAA298E6F36}"/>
-              </a:ext>
-            </a:extLst>
-          </p:cNvPr>
-          <p:cNvSpPr>
-            <a:spLocks noGrp="1"/>
-          </p:cNvSpPr>
-          <p:nvPr>
-            <p:ph type="body" idx="1"/>
-          </p:nvPr>
-        </p:nvSpPr>
-        <p:spPr/>
-        <p:txBody>
-          <a:bodyPr/>
-          <a:lstStyle/>
-          <a:p>
-            <a:endParaRPr lang="de-DE"/>
-          </a:p>
-        </p:txBody>
-      </p:sp>
+              <a:t>Logisches Modell</a:t>
+            </a:r>
+            <a:br>
+              <a:rPr lang="de-DE" dirty="0"/>
+            </a:br>
+            <a:r>
+              <a:rPr lang="de-DE" dirty="0"/>
+              <a:t>Galaxy Schema</a:t>
+            </a:r>
+          </a:p>
+        </p:txBody>
+      </p:sp>
+      <p:pic>
+        <p:nvPicPr>
+          <p:cNvPr id="5" name="Inhaltsplatzhalter 4">
+            <a:extLst>
+              <a:ext uri="{FF2B5EF4-FFF2-40B4-BE49-F238E27FC236}">
+                <a16:creationId xmlns:a16="http://schemas.microsoft.com/office/drawing/2014/main" id="{525D996C-32F6-0F32-53F9-94DC195EDD2E}"/>
+              </a:ext>
+            </a:extLst>
+          </p:cNvPr>
+          <p:cNvPicPr>
+            <a:picLocks noGrp="1" noChangeAspect="1"/>
+          </p:cNvPicPr>
+          <p:nvPr>
+            <p:ph idx="1"/>
+          </p:nvPr>
+        </p:nvPicPr>
+        <p:blipFill>
+          <a:blip r:embed="rId3">
+            <a:extLst>
+              <a:ext uri="{28A0092B-C50C-407E-A947-70E740481C1C}">
+                <a14:useLocalDpi xmlns:a14="http://schemas.microsoft.com/office/drawing/2010/main" val="0"/>
+              </a:ext>
+            </a:extLst>
+          </a:blip>
+          <a:srcRect/>
+          <a:stretch/>
+        </p:blipFill>
+        <p:spPr>
+          <a:xfrm>
+            <a:off x="5155932" y="0"/>
+            <a:ext cx="5941996" cy="6727898"/>
+          </a:xfrm>
+          <a:prstGeom prst="rect">
+            <a:avLst/>
+          </a:prstGeom>
+        </p:spPr>
+      </p:pic>
     </p:spTree>
     <p:extLst>
       <p:ext uri="{BB962C8B-B14F-4D97-AF65-F5344CB8AC3E}">
-        <p14:creationId xmlns:p14="http://schemas.microsoft.com/office/powerpoint/2010/main" val="2824883227"/>
+        <p14:creationId xmlns:p14="http://schemas.microsoft.com/office/powerpoint/2010/main" val="763179585"/>
       </p:ext>
     </p:extLst>
   </p:cSld>

</xml_diff>